<commit_message>
11/8 Refactored Java FP to Java deck
</commit_message>
<xml_diff>
--- a/Container Technologies.pptx
+++ b/Container Technologies.pptx
@@ -14,10 +14,16 @@
     <p:sldId id="268" r:id="rId8"/>
     <p:sldId id="270" r:id="rId9"/>
     <p:sldId id="269" r:id="rId10"/>
-    <p:sldId id="265" r:id="rId11"/>
-    <p:sldId id="266" r:id="rId12"/>
-    <p:sldId id="267" r:id="rId13"/>
-    <p:sldId id="259" r:id="rId14"/>
+    <p:sldId id="271" r:id="rId11"/>
+    <p:sldId id="272" r:id="rId12"/>
+    <p:sldId id="273" r:id="rId13"/>
+    <p:sldId id="274" r:id="rId14"/>
+    <p:sldId id="275" r:id="rId15"/>
+    <p:sldId id="276" r:id="rId16"/>
+    <p:sldId id="265" r:id="rId17"/>
+    <p:sldId id="266" r:id="rId18"/>
+    <p:sldId id="267" r:id="rId19"/>
+    <p:sldId id="259" r:id="rId20"/>
   </p:sldIdLst>
   <p:sldSz cx="12192000" cy="6858000"/>
   <p:notesSz cx="6858000" cy="9144000"/>
@@ -273,7 +279,7 @@
           <a:p>
             <a:fld id="{0E34E9A3-28F9-49BC-BC4E-5AF907695DF0}" type="datetimeFigureOut">
               <a:rPr lang="en-IN" smtClean="0"/>
-              <a:t>06-05-2025</a:t>
+              <a:t>07-08-2025</a:t>
             </a:fld>
             <a:endParaRPr lang="en-IN"/>
           </a:p>
@@ -473,7 +479,7 @@
           <a:p>
             <a:fld id="{0E34E9A3-28F9-49BC-BC4E-5AF907695DF0}" type="datetimeFigureOut">
               <a:rPr lang="en-IN" smtClean="0"/>
-              <a:t>06-05-2025</a:t>
+              <a:t>07-08-2025</a:t>
             </a:fld>
             <a:endParaRPr lang="en-IN"/>
           </a:p>
@@ -683,7 +689,7 @@
           <a:p>
             <a:fld id="{0E34E9A3-28F9-49BC-BC4E-5AF907695DF0}" type="datetimeFigureOut">
               <a:rPr lang="en-IN" smtClean="0"/>
-              <a:t>06-05-2025</a:t>
+              <a:t>07-08-2025</a:t>
             </a:fld>
             <a:endParaRPr lang="en-IN"/>
           </a:p>
@@ -883,7 +889,7 @@
           <a:p>
             <a:fld id="{0E34E9A3-28F9-49BC-BC4E-5AF907695DF0}" type="datetimeFigureOut">
               <a:rPr lang="en-IN" smtClean="0"/>
-              <a:t>06-05-2025</a:t>
+              <a:t>07-08-2025</a:t>
             </a:fld>
             <a:endParaRPr lang="en-IN"/>
           </a:p>
@@ -1159,7 +1165,7 @@
           <a:p>
             <a:fld id="{0E34E9A3-28F9-49BC-BC4E-5AF907695DF0}" type="datetimeFigureOut">
               <a:rPr lang="en-IN" smtClean="0"/>
-              <a:t>06-05-2025</a:t>
+              <a:t>07-08-2025</a:t>
             </a:fld>
             <a:endParaRPr lang="en-IN"/>
           </a:p>
@@ -1427,7 +1433,7 @@
           <a:p>
             <a:fld id="{0E34E9A3-28F9-49BC-BC4E-5AF907695DF0}" type="datetimeFigureOut">
               <a:rPr lang="en-IN" smtClean="0"/>
-              <a:t>06-05-2025</a:t>
+              <a:t>07-08-2025</a:t>
             </a:fld>
             <a:endParaRPr lang="en-IN"/>
           </a:p>
@@ -1842,7 +1848,7 @@
           <a:p>
             <a:fld id="{0E34E9A3-28F9-49BC-BC4E-5AF907695DF0}" type="datetimeFigureOut">
               <a:rPr lang="en-IN" smtClean="0"/>
-              <a:t>06-05-2025</a:t>
+              <a:t>07-08-2025</a:t>
             </a:fld>
             <a:endParaRPr lang="en-IN"/>
           </a:p>
@@ -1984,7 +1990,7 @@
           <a:p>
             <a:fld id="{0E34E9A3-28F9-49BC-BC4E-5AF907695DF0}" type="datetimeFigureOut">
               <a:rPr lang="en-IN" smtClean="0"/>
-              <a:t>06-05-2025</a:t>
+              <a:t>07-08-2025</a:t>
             </a:fld>
             <a:endParaRPr lang="en-IN"/>
           </a:p>
@@ -2097,7 +2103,7 @@
           <a:p>
             <a:fld id="{0E34E9A3-28F9-49BC-BC4E-5AF907695DF0}" type="datetimeFigureOut">
               <a:rPr lang="en-IN" smtClean="0"/>
-              <a:t>06-05-2025</a:t>
+              <a:t>07-08-2025</a:t>
             </a:fld>
             <a:endParaRPr lang="en-IN"/>
           </a:p>
@@ -2410,7 +2416,7 @@
           <a:p>
             <a:fld id="{0E34E9A3-28F9-49BC-BC4E-5AF907695DF0}" type="datetimeFigureOut">
               <a:rPr lang="en-IN" smtClean="0"/>
-              <a:t>06-05-2025</a:t>
+              <a:t>07-08-2025</a:t>
             </a:fld>
             <a:endParaRPr lang="en-IN"/>
           </a:p>
@@ -2699,7 +2705,7 @@
           <a:p>
             <a:fld id="{0E34E9A3-28F9-49BC-BC4E-5AF907695DF0}" type="datetimeFigureOut">
               <a:rPr lang="en-IN" smtClean="0"/>
-              <a:t>06-05-2025</a:t>
+              <a:t>07-08-2025</a:t>
             </a:fld>
             <a:endParaRPr lang="en-IN"/>
           </a:p>
@@ -2942,7 +2948,7 @@
           <a:p>
             <a:fld id="{0E34E9A3-28F9-49BC-BC4E-5AF907695DF0}" type="datetimeFigureOut">
               <a:rPr lang="en-IN" smtClean="0"/>
-              <a:t>06-05-2025</a:t>
+              <a:t>07-08-2025</a:t>
             </a:fld>
             <a:endParaRPr lang="en-IN"/>
           </a:p>
@@ -3450,6 +3456,1652 @@
           <p:cNvPr id="2" name="Title 1">
             <a:extLst>
               <a:ext uri="{FF2B5EF4-FFF2-40B4-BE49-F238E27FC236}">
+                <a16:creationId xmlns:a16="http://schemas.microsoft.com/office/drawing/2014/main" id="{E44C68C2-0AAC-DF0A-B8C0-C88DD6D5AF98}"/>
+              </a:ext>
+            </a:extLst>
+          </p:cNvPr>
+          <p:cNvSpPr>
+            <a:spLocks noGrp="1"/>
+          </p:cNvSpPr>
+          <p:nvPr>
+            <p:ph type="title"/>
+          </p:nvPr>
+        </p:nvSpPr>
+        <p:spPr>
+          <a:xfrm>
+            <a:off x="838200" y="365126"/>
+            <a:ext cx="10515600" cy="418646"/>
+          </a:xfrm>
+        </p:spPr>
+        <p:txBody>
+          <a:bodyPr>
+            <a:normAutofit fontScale="90000"/>
+          </a:bodyPr>
+          <a:lstStyle/>
+          <a:p>
+            <a:r>
+              <a:rPr lang="en-IN" dirty="0"/>
+              <a:t>Helm vs k8s</a:t>
+            </a:r>
+          </a:p>
+        </p:txBody>
+      </p:sp>
+      <p:pic>
+        <p:nvPicPr>
+          <p:cNvPr id="4" name="Picture 3">
+            <a:extLst>
+              <a:ext uri="{FF2B5EF4-FFF2-40B4-BE49-F238E27FC236}">
+                <a16:creationId xmlns:a16="http://schemas.microsoft.com/office/drawing/2014/main" id="{754ED314-FB77-06FC-1E87-9EB316C16501}"/>
+              </a:ext>
+            </a:extLst>
+          </p:cNvPr>
+          <p:cNvPicPr>
+            <a:picLocks noChangeAspect="1"/>
+          </p:cNvPicPr>
+          <p:nvPr/>
+        </p:nvPicPr>
+        <p:blipFill>
+          <a:blip r:embed="rId2"/>
+          <a:stretch>
+            <a:fillRect/>
+          </a:stretch>
+        </p:blipFill>
+        <p:spPr>
+          <a:xfrm>
+            <a:off x="228601" y="1479840"/>
+            <a:ext cx="5405078" cy="2765589"/>
+          </a:xfrm>
+          <a:prstGeom prst="rect">
+            <a:avLst/>
+          </a:prstGeom>
+        </p:spPr>
+      </p:pic>
+      <p:pic>
+        <p:nvPicPr>
+          <p:cNvPr id="6" name="Picture 5">
+            <a:extLst>
+              <a:ext uri="{FF2B5EF4-FFF2-40B4-BE49-F238E27FC236}">
+                <a16:creationId xmlns:a16="http://schemas.microsoft.com/office/drawing/2014/main" id="{DE80D423-2BC5-6AEA-B923-16F0B8E54475}"/>
+              </a:ext>
+            </a:extLst>
+          </p:cNvPr>
+          <p:cNvPicPr>
+            <a:picLocks noChangeAspect="1"/>
+          </p:cNvPicPr>
+          <p:nvPr/>
+        </p:nvPicPr>
+        <p:blipFill>
+          <a:blip r:embed="rId3"/>
+          <a:stretch>
+            <a:fillRect/>
+          </a:stretch>
+        </p:blipFill>
+        <p:spPr>
+          <a:xfrm>
+            <a:off x="6259286" y="1479840"/>
+            <a:ext cx="5704113" cy="2721571"/>
+          </a:xfrm>
+          <a:prstGeom prst="rect">
+            <a:avLst/>
+          </a:prstGeom>
+        </p:spPr>
+      </p:pic>
+      <p:sp>
+        <p:nvSpPr>
+          <p:cNvPr id="8" name="TextBox 7">
+            <a:extLst>
+              <a:ext uri="{FF2B5EF4-FFF2-40B4-BE49-F238E27FC236}">
+                <a16:creationId xmlns:a16="http://schemas.microsoft.com/office/drawing/2014/main" id="{38CC545B-103C-DE3C-CED6-742BB239E021}"/>
+              </a:ext>
+            </a:extLst>
+          </p:cNvPr>
+          <p:cNvSpPr txBox="1"/>
+          <p:nvPr/>
+        </p:nvSpPr>
+        <p:spPr>
+          <a:xfrm>
+            <a:off x="2585679" y="5193494"/>
+            <a:ext cx="6096000" cy="369332"/>
+          </a:xfrm>
+          <a:prstGeom prst="rect">
+            <a:avLst/>
+          </a:prstGeom>
+          <a:noFill/>
+        </p:spPr>
+        <p:txBody>
+          <a:bodyPr wrap="square">
+            <a:spAutoFit/>
+          </a:bodyPr>
+          <a:lstStyle/>
+          <a:p>
+            <a:r>
+              <a:rPr lang="en-IN" dirty="0">
+                <a:hlinkClick r:id="rId4"/>
+              </a:rPr>
+              <a:t>https://www.youtube.com/watch?v=DQk8HOVlumI</a:t>
+            </a:r>
+            <a:r>
+              <a:rPr lang="en-IN" dirty="0"/>
+              <a:t> </a:t>
+            </a:r>
+          </a:p>
+        </p:txBody>
+      </p:sp>
+    </p:spTree>
+    <p:extLst>
+      <p:ext uri="{BB962C8B-B14F-4D97-AF65-F5344CB8AC3E}">
+        <p14:creationId xmlns:p14="http://schemas.microsoft.com/office/powerpoint/2010/main" val="556520814"/>
+      </p:ext>
+    </p:extLst>
+  </p:cSld>
+  <p:clrMapOvr>
+    <a:masterClrMapping/>
+  </p:clrMapOvr>
+</p:sld>
+</file>
+
+<file path=ppt/slides/slide11.xml><?xml version="1.0" encoding="utf-8"?>
+<p:sld xmlns:a="http://schemas.openxmlformats.org/drawingml/2006/main" xmlns:r="http://schemas.openxmlformats.org/officeDocument/2006/relationships" xmlns:p="http://schemas.openxmlformats.org/presentationml/2006/main">
+  <p:cSld>
+    <p:spTree>
+      <p:nvGrpSpPr>
+        <p:cNvPr id="1" name=""/>
+        <p:cNvGrpSpPr/>
+        <p:nvPr/>
+      </p:nvGrpSpPr>
+      <p:grpSpPr>
+        <a:xfrm>
+          <a:off x="0" y="0"/>
+          <a:ext cx="0" cy="0"/>
+          <a:chOff x="0" y="0"/>
+          <a:chExt cx="0" cy="0"/>
+        </a:xfrm>
+      </p:grpSpPr>
+      <p:sp>
+        <p:nvSpPr>
+          <p:cNvPr id="3" name="TextBox 2">
+            <a:extLst>
+              <a:ext uri="{FF2B5EF4-FFF2-40B4-BE49-F238E27FC236}">
+                <a16:creationId xmlns:a16="http://schemas.microsoft.com/office/drawing/2014/main" id="{295AD2CA-8F9B-D80D-2FFC-355CADA19344}"/>
+              </a:ext>
+            </a:extLst>
+          </p:cNvPr>
+          <p:cNvSpPr txBox="1"/>
+          <p:nvPr/>
+        </p:nvSpPr>
+        <p:spPr>
+          <a:xfrm>
+            <a:off x="821872" y="158607"/>
+            <a:ext cx="9481457" cy="1107996"/>
+          </a:xfrm>
+          <a:prstGeom prst="rect">
+            <a:avLst/>
+          </a:prstGeom>
+          <a:noFill/>
+        </p:spPr>
+        <p:txBody>
+          <a:bodyPr wrap="square" rtlCol="0">
+            <a:spAutoFit/>
+          </a:bodyPr>
+          <a:lstStyle/>
+          <a:p>
+            <a:r>
+              <a:rPr lang="en-US" dirty="0"/>
+              <a:t>In </a:t>
+            </a:r>
+            <a:r>
+              <a:rPr lang="en-US" dirty="0">
+                <a:hlinkClick r:id="rId2" tooltip="Software architecture"/>
+              </a:rPr>
+              <a:t>software architecture</a:t>
+            </a:r>
+            <a:r>
+              <a:rPr lang="en-US" dirty="0"/>
+              <a:t>, a </a:t>
+            </a:r>
+            <a:r>
+              <a:rPr lang="en-US" b="1" dirty="0"/>
+              <a:t>service mesh</a:t>
+            </a:r>
+            <a:r>
+              <a:rPr lang="en-US" dirty="0"/>
+              <a:t> is a dedicated infrastructure layer for facilitating service-to-service communications between </a:t>
+            </a:r>
+            <a:r>
+              <a:rPr lang="en-US" dirty="0">
+                <a:hlinkClick r:id="rId3" tooltip="Service-oriented architecture"/>
+              </a:rPr>
+              <a:t>services</a:t>
+            </a:r>
+            <a:r>
+              <a:rPr lang="en-US" dirty="0"/>
+              <a:t> or </a:t>
+            </a:r>
+            <a:r>
+              <a:rPr lang="en-US" dirty="0">
+                <a:hlinkClick r:id="rId4" tooltip="Microservices"/>
+              </a:rPr>
+              <a:t>microservices</a:t>
+            </a:r>
+            <a:r>
+              <a:rPr lang="en-US" dirty="0"/>
+              <a:t> using a </a:t>
+            </a:r>
+            <a:r>
+              <a:rPr lang="en-US" dirty="0">
+                <a:hlinkClick r:id="rId5" tooltip="Proxy pattern"/>
+              </a:rPr>
+              <a:t>proxy</a:t>
+            </a:r>
+            <a:r>
+              <a:rPr lang="en-US" dirty="0"/>
+              <a:t>.</a:t>
+            </a:r>
+            <a:endParaRPr lang="en-US" baseline="30000" dirty="0"/>
+          </a:p>
+          <a:p>
+            <a:endParaRPr lang="en-US" baseline="30000" dirty="0"/>
+          </a:p>
+          <a:p>
+            <a:endParaRPr lang="en-IN" dirty="0"/>
+          </a:p>
+        </p:txBody>
+      </p:sp>
+      <p:sp>
+        <p:nvSpPr>
+          <p:cNvPr id="4" name="TextBox 3">
+            <a:extLst>
+              <a:ext uri="{FF2B5EF4-FFF2-40B4-BE49-F238E27FC236}">
+                <a16:creationId xmlns:a16="http://schemas.microsoft.com/office/drawing/2014/main" id="{5E6FBF4F-D878-D93A-7C5C-07EDD56B91BE}"/>
+              </a:ext>
+            </a:extLst>
+          </p:cNvPr>
+          <p:cNvSpPr txBox="1"/>
+          <p:nvPr/>
+        </p:nvSpPr>
+        <p:spPr>
+          <a:xfrm>
+            <a:off x="419101" y="1057694"/>
+            <a:ext cx="6047014" cy="4555093"/>
+          </a:xfrm>
+          <a:prstGeom prst="rect">
+            <a:avLst/>
+          </a:prstGeom>
+          <a:noFill/>
+        </p:spPr>
+        <p:txBody>
+          <a:bodyPr wrap="square" rtlCol="0">
+            <a:spAutoFit/>
+          </a:bodyPr>
+          <a:lstStyle/>
+          <a:p>
+            <a:r>
+              <a:rPr lang="en-IN" b="1" u="sng" dirty="0"/>
+              <a:t>Why use Service Mesh?</a:t>
+            </a:r>
+          </a:p>
+          <a:p>
+            <a:pPr marL="285750" indent="-285750">
+              <a:buFont typeface="Arial" panose="020B0604020202020204" pitchFamily="34" charset="0"/>
+              <a:buChar char="•"/>
+            </a:pPr>
+            <a:r>
+              <a:rPr lang="en-US" sz="1600" dirty="0"/>
+              <a:t>Manages Inter-Service Communication: In complex microservices architectures, services need to communicate with each other to fulfill a request. A service mesh acts as an intermediary, managing this communication, </a:t>
+            </a:r>
+            <a:r>
+              <a:rPr lang="en-US" sz="1600" dirty="0">
+                <a:hlinkClick r:id="rId6"/>
+              </a:rPr>
+              <a:t>according to Amazon.com</a:t>
+            </a:r>
+            <a:r>
+              <a:rPr lang="en-US" sz="1600" dirty="0"/>
+              <a:t>. Instead of services communicating directly, they send requests through the service mesh's proxies.</a:t>
+            </a:r>
+          </a:p>
+          <a:p>
+            <a:pPr marL="285750" indent="-285750">
+              <a:buFont typeface="Arial" panose="020B0604020202020204" pitchFamily="34" charset="0"/>
+              <a:buChar char="•"/>
+            </a:pPr>
+            <a:r>
+              <a:rPr lang="en-US" sz="1600" dirty="0"/>
+              <a:t>Decouples Business Logic from Network Concerns: Before service meshes, developers would often embed logic for tasks like load balancing, retries, and security into the code of each individual service. This led to duplicated effort and increased complexity within the application code. A service mesh abstracts these network-related functions into a separate infrastructure layer, allowing developers to focus on the core business logic of their services.</a:t>
+            </a:r>
+          </a:p>
+          <a:p>
+            <a:pPr marL="285750" indent="-285750">
+              <a:buFont typeface="Arial" panose="020B0604020202020204" pitchFamily="34" charset="0"/>
+              <a:buChar char="•"/>
+            </a:pPr>
+            <a:r>
+              <a:rPr lang="en-US" sz="1600" dirty="0"/>
+              <a:t>Enhances Manageability, Observability, and Security: A service mesh provides features that make it easier to manage, monitor, and secure microservices-based applications. </a:t>
+            </a:r>
+          </a:p>
+        </p:txBody>
+      </p:sp>
+      <p:sp>
+        <p:nvSpPr>
+          <p:cNvPr id="5" name="TextBox 4">
+            <a:extLst>
+              <a:ext uri="{FF2B5EF4-FFF2-40B4-BE49-F238E27FC236}">
+                <a16:creationId xmlns:a16="http://schemas.microsoft.com/office/drawing/2014/main" id="{AF4B5C58-D2F2-0C53-950A-42E1B945597C}"/>
+              </a:ext>
+            </a:extLst>
+          </p:cNvPr>
+          <p:cNvSpPr txBox="1"/>
+          <p:nvPr/>
+        </p:nvSpPr>
+        <p:spPr>
+          <a:xfrm>
+            <a:off x="6466115" y="1057694"/>
+            <a:ext cx="5562599" cy="5755422"/>
+          </a:xfrm>
+          <a:prstGeom prst="rect">
+            <a:avLst/>
+          </a:prstGeom>
+          <a:noFill/>
+        </p:spPr>
+        <p:txBody>
+          <a:bodyPr wrap="square" rtlCol="0">
+            <a:spAutoFit/>
+          </a:bodyPr>
+          <a:lstStyle/>
+          <a:p>
+            <a:r>
+              <a:rPr lang="en-US" sz="1600" b="1" u="sng" dirty="0"/>
+              <a:t>Benefits</a:t>
+            </a:r>
+          </a:p>
+          <a:p>
+            <a:pPr marL="285750" indent="-285750">
+              <a:buFont typeface="Arial" panose="020B0604020202020204" pitchFamily="34" charset="0"/>
+              <a:buChar char="•"/>
+            </a:pPr>
+            <a:r>
+              <a:rPr lang="en-US" sz="1600" dirty="0"/>
+              <a:t>Improved Observability: Service meshes offer built-in observability features like distributed tracing, metrics collection, and logging, giving insights into service behavior and performance. This helps identify bottlenecks and troubleshoot issues in complex microservices environments.</a:t>
+            </a:r>
+          </a:p>
+          <a:p>
+            <a:pPr marL="285750" indent="-285750">
+              <a:buFont typeface="Arial" panose="020B0604020202020204" pitchFamily="34" charset="0"/>
+              <a:buChar char="•"/>
+            </a:pPr>
+            <a:r>
+              <a:rPr lang="en-US" sz="1600" dirty="0"/>
+              <a:t>Enhanced Security: Service meshes provide security features such as mutual TLS (</a:t>
+            </a:r>
+            <a:r>
+              <a:rPr lang="en-US" sz="1600" dirty="0" err="1"/>
+              <a:t>mTLS</a:t>
+            </a:r>
+            <a:r>
+              <a:rPr lang="en-US" sz="1600" dirty="0"/>
+              <a:t>) encryption, ensuring secure communication between services. They can also enforce fine-grained access control policies.</a:t>
+            </a:r>
+          </a:p>
+          <a:p>
+            <a:pPr marL="285750" indent="-285750">
+              <a:buFont typeface="Arial" panose="020B0604020202020204" pitchFamily="34" charset="0"/>
+              <a:buChar char="•"/>
+            </a:pPr>
+            <a:r>
+              <a:rPr lang="en-US" sz="1600" dirty="0"/>
+              <a:t>Centralized Traffic Management: Service meshes enable fine-grained control over traffic flow between services, supporting features like load balancing, traffic splitting (for A/B testing or canary deployments), retries, and circuit breaking. This enhances reliability and resilience.</a:t>
+            </a:r>
+          </a:p>
+          <a:p>
+            <a:pPr marL="285750" indent="-285750">
+              <a:buFont typeface="Arial" panose="020B0604020202020204" pitchFamily="34" charset="0"/>
+              <a:buChar char="•"/>
+            </a:pPr>
+            <a:r>
+              <a:rPr lang="en-US" sz="1600" dirty="0"/>
+              <a:t>Increased Resilience and Reliability: By implementing features like circuit breaking, retries, and timeouts, service meshes help mitigate the impact of failures and network issues, improving the overall fault tolerance of the system.</a:t>
+            </a:r>
+          </a:p>
+          <a:p>
+            <a:pPr marL="285750" indent="-285750">
+              <a:buFont typeface="Arial" panose="020B0604020202020204" pitchFamily="34" charset="0"/>
+              <a:buChar char="•"/>
+            </a:pPr>
+            <a:r>
+              <a:rPr lang="en-US" sz="1600" dirty="0"/>
+              <a:t>Faster Development and Deployment: By abstracting network-related complexities, developers can focus on writing and deploying their core business logic more quickly. </a:t>
+            </a:r>
+          </a:p>
+          <a:p>
+            <a:endParaRPr lang="en-IN" sz="1600" dirty="0"/>
+          </a:p>
+        </p:txBody>
+      </p:sp>
+    </p:spTree>
+    <p:extLst>
+      <p:ext uri="{BB962C8B-B14F-4D97-AF65-F5344CB8AC3E}">
+        <p14:creationId xmlns:p14="http://schemas.microsoft.com/office/powerpoint/2010/main" val="3354836589"/>
+      </p:ext>
+    </p:extLst>
+  </p:cSld>
+  <p:clrMapOvr>
+    <a:masterClrMapping/>
+  </p:clrMapOvr>
+</p:sld>
+</file>
+
+<file path=ppt/slides/slide12.xml><?xml version="1.0" encoding="utf-8"?>
+<p:sld xmlns:a="http://schemas.openxmlformats.org/drawingml/2006/main" xmlns:r="http://schemas.openxmlformats.org/officeDocument/2006/relationships" xmlns:p="http://schemas.openxmlformats.org/presentationml/2006/main">
+  <p:cSld>
+    <p:spTree>
+      <p:nvGrpSpPr>
+        <p:cNvPr id="1" name=""/>
+        <p:cNvGrpSpPr/>
+        <p:nvPr/>
+      </p:nvGrpSpPr>
+      <p:grpSpPr>
+        <a:xfrm>
+          <a:off x="0" y="0"/>
+          <a:ext cx="0" cy="0"/>
+          <a:chOff x="0" y="0"/>
+          <a:chExt cx="0" cy="0"/>
+        </a:xfrm>
+      </p:grpSpPr>
+      <p:sp>
+        <p:nvSpPr>
+          <p:cNvPr id="3" name="TextBox 2">
+            <a:extLst>
+              <a:ext uri="{FF2B5EF4-FFF2-40B4-BE49-F238E27FC236}">
+                <a16:creationId xmlns:a16="http://schemas.microsoft.com/office/drawing/2014/main" id="{1A653D36-6DF3-05E5-F23D-555B26BB5569}"/>
+              </a:ext>
+            </a:extLst>
+          </p:cNvPr>
+          <p:cNvSpPr txBox="1"/>
+          <p:nvPr/>
+        </p:nvSpPr>
+        <p:spPr>
+          <a:xfrm>
+            <a:off x="446314" y="300315"/>
+            <a:ext cx="5475515" cy="4272965"/>
+          </a:xfrm>
+          <a:prstGeom prst="rect">
+            <a:avLst/>
+          </a:prstGeom>
+          <a:noFill/>
+        </p:spPr>
+        <p:txBody>
+          <a:bodyPr wrap="square">
+            <a:spAutoFit/>
+          </a:bodyPr>
+          <a:lstStyle/>
+          <a:p>
+            <a:pPr algn="l">
+              <a:lnSpc>
+                <a:spcPts val="2100"/>
+              </a:lnSpc>
+              <a:spcBef>
+                <a:spcPts val="2250"/>
+              </a:spcBef>
+              <a:spcAft>
+                <a:spcPts val="2250"/>
+              </a:spcAft>
+              <a:buNone/>
+            </a:pPr>
+            <a:r>
+              <a:rPr lang="en-US" sz="1600" b="1" i="0" u="sng" dirty="0">
+                <a:effectLst/>
+                <a:latin typeface="Google Sans"/>
+              </a:rPr>
+              <a:t>Challenges</a:t>
+            </a:r>
+          </a:p>
+          <a:p>
+            <a:pPr algn="l">
+              <a:lnSpc>
+                <a:spcPts val="1800"/>
+              </a:lnSpc>
+              <a:spcBef>
+                <a:spcPts val="1200"/>
+              </a:spcBef>
+              <a:spcAft>
+                <a:spcPts val="600"/>
+              </a:spcAft>
+              <a:buFont typeface="Arial" panose="020B0604020202020204" pitchFamily="34" charset="0"/>
+              <a:buChar char="•"/>
+            </a:pPr>
+            <a:r>
+              <a:rPr lang="en-US" sz="1600" b="0" i="0" dirty="0">
+                <a:effectLst/>
+                <a:latin typeface="Google Sans"/>
+              </a:rPr>
+              <a:t>Increased Complexity: Implementing and managing a service mesh introduces additional components and overhead to the infrastructure.</a:t>
+            </a:r>
+          </a:p>
+          <a:p>
+            <a:pPr algn="l">
+              <a:lnSpc>
+                <a:spcPts val="1800"/>
+              </a:lnSpc>
+              <a:spcBef>
+                <a:spcPts val="1200"/>
+              </a:spcBef>
+              <a:spcAft>
+                <a:spcPts val="600"/>
+              </a:spcAft>
+              <a:buFont typeface="Arial" panose="020B0604020202020204" pitchFamily="34" charset="0"/>
+              <a:buChar char="•"/>
+            </a:pPr>
+            <a:r>
+              <a:rPr lang="en-US" sz="1600" b="0" i="0" dirty="0">
+                <a:effectLst/>
+                <a:latin typeface="Google Sans"/>
+              </a:rPr>
+              <a:t>Resource Consumption: Sidecar proxies consume additional CPU and memory, which can impact performance, particularly in large-scale deployments.</a:t>
+            </a:r>
+          </a:p>
+          <a:p>
+            <a:pPr algn="l">
+              <a:lnSpc>
+                <a:spcPts val="1800"/>
+              </a:lnSpc>
+              <a:spcBef>
+                <a:spcPts val="1200"/>
+              </a:spcBef>
+              <a:spcAft>
+                <a:spcPts val="600"/>
+              </a:spcAft>
+              <a:buFont typeface="Arial" panose="020B0604020202020204" pitchFamily="34" charset="0"/>
+              <a:buChar char="•"/>
+            </a:pPr>
+            <a:r>
+              <a:rPr lang="en-US" sz="1600" b="0" i="0" dirty="0">
+                <a:effectLst/>
+                <a:latin typeface="Google Sans"/>
+              </a:rPr>
+              <a:t>Learning Curve: Teams need to acquire expertise in service mesh technologies to effectively configure and troubleshoot them.</a:t>
+            </a:r>
+          </a:p>
+          <a:p>
+            <a:pPr algn="l">
+              <a:lnSpc>
+                <a:spcPts val="1800"/>
+              </a:lnSpc>
+              <a:spcBef>
+                <a:spcPts val="1200"/>
+              </a:spcBef>
+              <a:spcAft>
+                <a:spcPts val="600"/>
+              </a:spcAft>
+              <a:buFont typeface="Arial" panose="020B0604020202020204" pitchFamily="34" charset="0"/>
+              <a:buChar char="•"/>
+            </a:pPr>
+            <a:r>
+              <a:rPr lang="en-US" sz="1600" b="0" i="0" dirty="0">
+                <a:effectLst/>
+                <a:latin typeface="Google Sans"/>
+              </a:rPr>
+              <a:t>Potential Vendor Lock-in: Some service mesh solutions are tightly integrated with specific platforms, which could limit flexibility and portability. </a:t>
+            </a:r>
+          </a:p>
+        </p:txBody>
+      </p:sp>
+      <p:sp>
+        <p:nvSpPr>
+          <p:cNvPr id="5" name="TextBox 4">
+            <a:extLst>
+              <a:ext uri="{FF2B5EF4-FFF2-40B4-BE49-F238E27FC236}">
+                <a16:creationId xmlns:a16="http://schemas.microsoft.com/office/drawing/2014/main" id="{0C3FA19D-3476-BFA9-26BB-343559976ADC}"/>
+              </a:ext>
+            </a:extLst>
+          </p:cNvPr>
+          <p:cNvSpPr txBox="1"/>
+          <p:nvPr/>
+        </p:nvSpPr>
+        <p:spPr>
+          <a:xfrm>
+            <a:off x="6542314" y="300315"/>
+            <a:ext cx="4724400" cy="3580467"/>
+          </a:xfrm>
+          <a:prstGeom prst="rect">
+            <a:avLst/>
+          </a:prstGeom>
+          <a:noFill/>
+        </p:spPr>
+        <p:txBody>
+          <a:bodyPr wrap="square">
+            <a:spAutoFit/>
+          </a:bodyPr>
+          <a:lstStyle/>
+          <a:p>
+            <a:pPr algn="l">
+              <a:lnSpc>
+                <a:spcPts val="2100"/>
+              </a:lnSpc>
+              <a:spcBef>
+                <a:spcPts val="2250"/>
+              </a:spcBef>
+              <a:spcAft>
+                <a:spcPts val="2250"/>
+              </a:spcAft>
+              <a:buNone/>
+            </a:pPr>
+            <a:r>
+              <a:rPr lang="en-US" sz="1600" b="1" i="0" u="sng" dirty="0">
+                <a:effectLst/>
+                <a:latin typeface="Google Sans"/>
+              </a:rPr>
+              <a:t>Popular Service Mesh Implementations</a:t>
+            </a:r>
+          </a:p>
+          <a:p>
+            <a:pPr algn="l">
+              <a:lnSpc>
+                <a:spcPts val="1800"/>
+              </a:lnSpc>
+              <a:spcBef>
+                <a:spcPts val="1200"/>
+              </a:spcBef>
+              <a:spcAft>
+                <a:spcPts val="600"/>
+              </a:spcAft>
+              <a:buFont typeface="Arial" panose="020B0604020202020204" pitchFamily="34" charset="0"/>
+              <a:buChar char="•"/>
+            </a:pPr>
+            <a:r>
+              <a:rPr lang="en-US" sz="1600" b="0" i="0" dirty="0">
+                <a:effectLst/>
+                <a:latin typeface="Google Sans"/>
+              </a:rPr>
+              <a:t>Istio: A widely adopted, feature-rich service mesh, often used with Kubernetes.</a:t>
+            </a:r>
+          </a:p>
+          <a:p>
+            <a:pPr algn="l">
+              <a:lnSpc>
+                <a:spcPts val="1800"/>
+              </a:lnSpc>
+              <a:spcBef>
+                <a:spcPts val="1200"/>
+              </a:spcBef>
+              <a:spcAft>
+                <a:spcPts val="600"/>
+              </a:spcAft>
+              <a:buFont typeface="Arial" panose="020B0604020202020204" pitchFamily="34" charset="0"/>
+              <a:buChar char="•"/>
+            </a:pPr>
+            <a:r>
+              <a:rPr lang="en-US" sz="1600" b="0" i="0" dirty="0" err="1">
+                <a:effectLst/>
+                <a:latin typeface="Google Sans"/>
+              </a:rPr>
+              <a:t>Linkerd</a:t>
+            </a:r>
+            <a:r>
+              <a:rPr lang="en-US" sz="1600" b="0" i="0" dirty="0">
+                <a:effectLst/>
+                <a:latin typeface="Google Sans"/>
+              </a:rPr>
+              <a:t>: A lightweight and easy-to-use service mesh focused on simplicity and performance.</a:t>
+            </a:r>
+          </a:p>
+          <a:p>
+            <a:pPr algn="l">
+              <a:lnSpc>
+                <a:spcPts val="1800"/>
+              </a:lnSpc>
+              <a:spcBef>
+                <a:spcPts val="1200"/>
+              </a:spcBef>
+              <a:spcAft>
+                <a:spcPts val="600"/>
+              </a:spcAft>
+              <a:buFont typeface="Arial" panose="020B0604020202020204" pitchFamily="34" charset="0"/>
+              <a:buChar char="•"/>
+            </a:pPr>
+            <a:r>
+              <a:rPr lang="en-US" sz="1600" b="0" i="0" dirty="0">
+                <a:effectLst/>
+                <a:latin typeface="Google Sans"/>
+              </a:rPr>
+              <a:t>Consul Connect: Offered by </a:t>
+            </a:r>
+            <a:r>
+              <a:rPr lang="en-US" sz="1600" b="0" i="0" dirty="0" err="1">
+                <a:effectLst/>
+                <a:latin typeface="Google Sans"/>
+              </a:rPr>
+              <a:t>HashiCorp</a:t>
+            </a:r>
+            <a:r>
+              <a:rPr lang="en-US" sz="1600" b="0" i="0" dirty="0">
+                <a:effectLst/>
+                <a:latin typeface="Google Sans"/>
+              </a:rPr>
+              <a:t>, it provides service mesh features as part of its service discovery and configuration platform.</a:t>
+            </a:r>
+          </a:p>
+          <a:p>
+            <a:pPr algn="l">
+              <a:lnSpc>
+                <a:spcPts val="1800"/>
+              </a:lnSpc>
+              <a:spcBef>
+                <a:spcPts val="1200"/>
+              </a:spcBef>
+              <a:spcAft>
+                <a:spcPts val="600"/>
+              </a:spcAft>
+              <a:buFont typeface="Arial" panose="020B0604020202020204" pitchFamily="34" charset="0"/>
+              <a:buChar char="•"/>
+            </a:pPr>
+            <a:r>
+              <a:rPr lang="en-US" sz="1600" b="0" i="0" dirty="0">
+                <a:effectLst/>
+                <a:latin typeface="Google Sans"/>
+              </a:rPr>
+              <a:t>AWS App Mesh: Amazon's fully managed service mesh, tightly integrated with AWS services. </a:t>
+            </a:r>
+          </a:p>
+        </p:txBody>
+      </p:sp>
+      <p:sp>
+        <p:nvSpPr>
+          <p:cNvPr id="4" name="TextBox 3">
+            <a:extLst>
+              <a:ext uri="{FF2B5EF4-FFF2-40B4-BE49-F238E27FC236}">
+                <a16:creationId xmlns:a16="http://schemas.microsoft.com/office/drawing/2014/main" id="{E1E669F3-7F01-D789-6932-FFEA5E8D2435}"/>
+              </a:ext>
+            </a:extLst>
+          </p:cNvPr>
+          <p:cNvSpPr txBox="1"/>
+          <p:nvPr/>
+        </p:nvSpPr>
+        <p:spPr>
+          <a:xfrm>
+            <a:off x="3799114" y="5584762"/>
+            <a:ext cx="6096000" cy="923330"/>
+          </a:xfrm>
+          <a:prstGeom prst="rect">
+            <a:avLst/>
+          </a:prstGeom>
+          <a:noFill/>
+        </p:spPr>
+        <p:txBody>
+          <a:bodyPr wrap="square">
+            <a:spAutoFit/>
+          </a:bodyPr>
+          <a:lstStyle/>
+          <a:p>
+            <a:r>
+              <a:rPr lang="en-IN" dirty="0">
+                <a:hlinkClick r:id="rId2"/>
+              </a:rPr>
+              <a:t>https://www.youtube.com/watch?v=16fgzklcF7Y</a:t>
+            </a:r>
+            <a:r>
+              <a:rPr lang="en-IN" dirty="0"/>
+              <a:t> </a:t>
+            </a:r>
+          </a:p>
+          <a:p>
+            <a:endParaRPr lang="en-IN" dirty="0"/>
+          </a:p>
+          <a:p>
+            <a:r>
+              <a:rPr lang="en-IN" dirty="0">
+                <a:hlinkClick r:id="rId3"/>
+              </a:rPr>
+              <a:t>https://www.youtube.com/watch?v=voAyroDb6xk</a:t>
+            </a:r>
+            <a:r>
+              <a:rPr lang="en-IN" dirty="0"/>
+              <a:t> </a:t>
+            </a:r>
+          </a:p>
+        </p:txBody>
+      </p:sp>
+    </p:spTree>
+    <p:extLst>
+      <p:ext uri="{BB962C8B-B14F-4D97-AF65-F5344CB8AC3E}">
+        <p14:creationId xmlns:p14="http://schemas.microsoft.com/office/powerpoint/2010/main" val="3416145772"/>
+      </p:ext>
+    </p:extLst>
+  </p:cSld>
+  <p:clrMapOvr>
+    <a:masterClrMapping/>
+  </p:clrMapOvr>
+</p:sld>
+</file>
+
+<file path=ppt/slides/slide13.xml><?xml version="1.0" encoding="utf-8"?>
+<p:sld xmlns:a="http://schemas.openxmlformats.org/drawingml/2006/main" xmlns:r="http://schemas.openxmlformats.org/officeDocument/2006/relationships" xmlns:p="http://schemas.openxmlformats.org/presentationml/2006/main">
+  <p:cSld>
+    <p:spTree>
+      <p:nvGrpSpPr>
+        <p:cNvPr id="1" name=""/>
+        <p:cNvGrpSpPr/>
+        <p:nvPr/>
+      </p:nvGrpSpPr>
+      <p:grpSpPr>
+        <a:xfrm>
+          <a:off x="0" y="0"/>
+          <a:ext cx="0" cy="0"/>
+          <a:chOff x="0" y="0"/>
+          <a:chExt cx="0" cy="0"/>
+        </a:xfrm>
+      </p:grpSpPr>
+      <p:pic>
+        <p:nvPicPr>
+          <p:cNvPr id="5" name="Picture 4">
+            <a:extLst>
+              <a:ext uri="{FF2B5EF4-FFF2-40B4-BE49-F238E27FC236}">
+                <a16:creationId xmlns:a16="http://schemas.microsoft.com/office/drawing/2014/main" id="{D0CCEFB9-90A9-A3C6-5C17-0B5044C49B32}"/>
+              </a:ext>
+            </a:extLst>
+          </p:cNvPr>
+          <p:cNvPicPr>
+            <a:picLocks noChangeAspect="1"/>
+          </p:cNvPicPr>
+          <p:nvPr/>
+        </p:nvPicPr>
+        <p:blipFill>
+          <a:blip r:embed="rId2"/>
+          <a:stretch>
+            <a:fillRect/>
+          </a:stretch>
+        </p:blipFill>
+        <p:spPr>
+          <a:xfrm>
+            <a:off x="2002971" y="720789"/>
+            <a:ext cx="8186057" cy="3736226"/>
+          </a:xfrm>
+          <a:prstGeom prst="rect">
+            <a:avLst/>
+          </a:prstGeom>
+        </p:spPr>
+      </p:pic>
+      <p:sp>
+        <p:nvSpPr>
+          <p:cNvPr id="7" name="TextBox 6">
+            <a:extLst>
+              <a:ext uri="{FF2B5EF4-FFF2-40B4-BE49-F238E27FC236}">
+                <a16:creationId xmlns:a16="http://schemas.microsoft.com/office/drawing/2014/main" id="{DAADB940-FF6B-1419-53A5-FAF3EB42B243}"/>
+              </a:ext>
+            </a:extLst>
+          </p:cNvPr>
+          <p:cNvSpPr txBox="1"/>
+          <p:nvPr/>
+        </p:nvSpPr>
+        <p:spPr>
+          <a:xfrm>
+            <a:off x="195943" y="4791633"/>
+            <a:ext cx="6096000" cy="1480534"/>
+          </a:xfrm>
+          <a:prstGeom prst="rect">
+            <a:avLst/>
+          </a:prstGeom>
+          <a:noFill/>
+        </p:spPr>
+        <p:txBody>
+          <a:bodyPr wrap="square">
+            <a:spAutoFit/>
+          </a:bodyPr>
+          <a:lstStyle/>
+          <a:p>
+            <a:pPr algn="l">
+              <a:lnSpc>
+                <a:spcPts val="1800"/>
+              </a:lnSpc>
+              <a:spcBef>
+                <a:spcPts val="1200"/>
+              </a:spcBef>
+              <a:spcAft>
+                <a:spcPts val="600"/>
+              </a:spcAft>
+            </a:pPr>
+            <a:r>
+              <a:rPr lang="en-US" b="1" i="0" dirty="0">
+                <a:effectLst/>
+                <a:latin typeface="Google Sans"/>
+              </a:rPr>
+              <a:t>Data Plane</a:t>
+            </a:r>
+            <a:r>
+              <a:rPr lang="en-US" b="0" i="0" dirty="0">
+                <a:effectLst/>
+                <a:latin typeface="Google Sans"/>
+              </a:rPr>
+              <a:t>: This consists of lightweight proxies, often referred to as sidecars, deployed alongside each service instance. These sidecars intercept and manage all incoming and outgoing traffic for the service. They handle tasks such as traffic routing, load balancing, enforcing security policies, and collecting telemetry data.</a:t>
+            </a:r>
+          </a:p>
+        </p:txBody>
+      </p:sp>
+      <p:sp>
+        <p:nvSpPr>
+          <p:cNvPr id="9" name="TextBox 8">
+            <a:extLst>
+              <a:ext uri="{FF2B5EF4-FFF2-40B4-BE49-F238E27FC236}">
+                <a16:creationId xmlns:a16="http://schemas.microsoft.com/office/drawing/2014/main" id="{AC786DCD-A686-EA34-D499-7B1106A09B2B}"/>
+              </a:ext>
+            </a:extLst>
+          </p:cNvPr>
+          <p:cNvSpPr txBox="1"/>
+          <p:nvPr/>
+        </p:nvSpPr>
+        <p:spPr>
+          <a:xfrm>
+            <a:off x="6400800" y="4676217"/>
+            <a:ext cx="6096000" cy="1711366"/>
+          </a:xfrm>
+          <a:prstGeom prst="rect">
+            <a:avLst/>
+          </a:prstGeom>
+          <a:noFill/>
+        </p:spPr>
+        <p:txBody>
+          <a:bodyPr wrap="square">
+            <a:spAutoFit/>
+          </a:bodyPr>
+          <a:lstStyle/>
+          <a:p>
+            <a:pPr algn="l">
+              <a:lnSpc>
+                <a:spcPts val="1800"/>
+              </a:lnSpc>
+              <a:spcBef>
+                <a:spcPts val="1200"/>
+              </a:spcBef>
+              <a:spcAft>
+                <a:spcPts val="600"/>
+              </a:spcAft>
+            </a:pPr>
+            <a:r>
+              <a:rPr lang="en-US" b="1" i="0" dirty="0">
+                <a:effectLst/>
+                <a:latin typeface="Google Sans"/>
+              </a:rPr>
+              <a:t>Control Plane</a:t>
+            </a:r>
+            <a:r>
+              <a:rPr lang="en-US" b="0" i="0" dirty="0">
+                <a:effectLst/>
+                <a:latin typeface="Google Sans"/>
+              </a:rPr>
+              <a:t>: This acts as the central management layer, configuring and monitoring the data plane. It allows administrators to define and distribute policies, security settings, and traffic rules to the sidecar proxies. The control plane also collects and aggregates telemetry data (metrics, logs, traces) from the sidecars, providing insights into the microservices' communication. </a:t>
+            </a:r>
+          </a:p>
+        </p:txBody>
+      </p:sp>
+      <p:sp>
+        <p:nvSpPr>
+          <p:cNvPr id="10" name="Title 1">
+            <a:extLst>
+              <a:ext uri="{FF2B5EF4-FFF2-40B4-BE49-F238E27FC236}">
+                <a16:creationId xmlns:a16="http://schemas.microsoft.com/office/drawing/2014/main" id="{2E09396C-2230-9183-37CE-A4D0AE7F61C8}"/>
+              </a:ext>
+            </a:extLst>
+          </p:cNvPr>
+          <p:cNvSpPr txBox="1">
+            <a:spLocks/>
+          </p:cNvSpPr>
+          <p:nvPr/>
+        </p:nvSpPr>
+        <p:spPr>
+          <a:xfrm>
+            <a:off x="195943" y="156301"/>
+            <a:ext cx="10515600" cy="429532"/>
+          </a:xfrm>
+          <a:prstGeom prst="rect">
+            <a:avLst/>
+          </a:prstGeom>
+        </p:spPr>
+        <p:txBody>
+          <a:bodyPr>
+            <a:normAutofit fontScale="60000" lnSpcReduction="20000"/>
+          </a:bodyPr>
+          <a:lstStyle>
+            <a:lvl1pPr algn="l" defTabSz="914400" rtl="0" eaLnBrk="1" latinLnBrk="0" hangingPunct="1">
+              <a:lnSpc>
+                <a:spcPct val="90000"/>
+              </a:lnSpc>
+              <a:spcBef>
+                <a:spcPct val="0"/>
+              </a:spcBef>
+              <a:buNone/>
+              <a:defRPr sz="4400" kern="1200">
+                <a:solidFill>
+                  <a:schemeClr val="tx1"/>
+                </a:solidFill>
+                <a:latin typeface="+mj-lt"/>
+                <a:ea typeface="+mj-ea"/>
+                <a:cs typeface="+mj-cs"/>
+              </a:defRPr>
+            </a:lvl1pPr>
+          </a:lstStyle>
+          <a:p>
+            <a:r>
+              <a:rPr lang="en-IN" dirty="0"/>
+              <a:t>Istio Architecture</a:t>
+            </a:r>
+          </a:p>
+        </p:txBody>
+      </p:sp>
+    </p:spTree>
+    <p:extLst>
+      <p:ext uri="{BB962C8B-B14F-4D97-AF65-F5344CB8AC3E}">
+        <p14:creationId xmlns:p14="http://schemas.microsoft.com/office/powerpoint/2010/main" val="3784443977"/>
+      </p:ext>
+    </p:extLst>
+  </p:cSld>
+  <p:clrMapOvr>
+    <a:masterClrMapping/>
+  </p:clrMapOvr>
+</p:sld>
+</file>
+
+<file path=ppt/slides/slide14.xml><?xml version="1.0" encoding="utf-8"?>
+<p:sld xmlns:a="http://schemas.openxmlformats.org/drawingml/2006/main" xmlns:r="http://schemas.openxmlformats.org/officeDocument/2006/relationships" xmlns:p="http://schemas.openxmlformats.org/presentationml/2006/main">
+  <p:cSld>
+    <p:spTree>
+      <p:nvGrpSpPr>
+        <p:cNvPr id="1" name=""/>
+        <p:cNvGrpSpPr/>
+        <p:nvPr/>
+      </p:nvGrpSpPr>
+      <p:grpSpPr>
+        <a:xfrm>
+          <a:off x="0" y="0"/>
+          <a:ext cx="0" cy="0"/>
+          <a:chOff x="0" y="0"/>
+          <a:chExt cx="0" cy="0"/>
+        </a:xfrm>
+      </p:grpSpPr>
+      <p:sp>
+        <p:nvSpPr>
+          <p:cNvPr id="2" name="Title 1">
+            <a:extLst>
+              <a:ext uri="{FF2B5EF4-FFF2-40B4-BE49-F238E27FC236}">
+                <a16:creationId xmlns:a16="http://schemas.microsoft.com/office/drawing/2014/main" id="{6273EB3B-2390-8E94-6F42-AA0B385FB3E7}"/>
+              </a:ext>
+            </a:extLst>
+          </p:cNvPr>
+          <p:cNvSpPr>
+            <a:spLocks noGrp="1"/>
+          </p:cNvSpPr>
+          <p:nvPr>
+            <p:ph type="title"/>
+          </p:nvPr>
+        </p:nvSpPr>
+        <p:spPr>
+          <a:xfrm>
+            <a:off x="838200" y="365126"/>
+            <a:ext cx="10515600" cy="505732"/>
+          </a:xfrm>
+        </p:spPr>
+        <p:txBody>
+          <a:bodyPr>
+            <a:normAutofit fontScale="90000"/>
+          </a:bodyPr>
+          <a:lstStyle/>
+          <a:p>
+            <a:r>
+              <a:rPr lang="en-IN" dirty="0"/>
+              <a:t>Virtual Service and Destination Rule</a:t>
+            </a:r>
+          </a:p>
+        </p:txBody>
+      </p:sp>
+      <p:pic>
+        <p:nvPicPr>
+          <p:cNvPr id="4" name="Picture 3">
+            <a:extLst>
+              <a:ext uri="{FF2B5EF4-FFF2-40B4-BE49-F238E27FC236}">
+                <a16:creationId xmlns:a16="http://schemas.microsoft.com/office/drawing/2014/main" id="{4EFEBBD6-7820-A001-6ADF-C476F538FA22}"/>
+              </a:ext>
+            </a:extLst>
+          </p:cNvPr>
+          <p:cNvPicPr>
+            <a:picLocks noChangeAspect="1"/>
+          </p:cNvPicPr>
+          <p:nvPr/>
+        </p:nvPicPr>
+        <p:blipFill>
+          <a:blip r:embed="rId2"/>
+          <a:stretch>
+            <a:fillRect/>
+          </a:stretch>
+        </p:blipFill>
+        <p:spPr>
+          <a:xfrm>
+            <a:off x="838200" y="1132112"/>
+            <a:ext cx="5000322" cy="5497287"/>
+          </a:xfrm>
+          <a:prstGeom prst="rect">
+            <a:avLst/>
+          </a:prstGeom>
+        </p:spPr>
+      </p:pic>
+      <p:sp>
+        <p:nvSpPr>
+          <p:cNvPr id="6" name="TextBox 5">
+            <a:extLst>
+              <a:ext uri="{FF2B5EF4-FFF2-40B4-BE49-F238E27FC236}">
+                <a16:creationId xmlns:a16="http://schemas.microsoft.com/office/drawing/2014/main" id="{2140ED62-484E-F38D-19B9-854BB6A9A6B3}"/>
+              </a:ext>
+            </a:extLst>
+          </p:cNvPr>
+          <p:cNvSpPr txBox="1"/>
+          <p:nvPr/>
+        </p:nvSpPr>
+        <p:spPr>
+          <a:xfrm>
+            <a:off x="6096000" y="942771"/>
+            <a:ext cx="5758544" cy="5875968"/>
+          </a:xfrm>
+          <a:prstGeom prst="rect">
+            <a:avLst/>
+          </a:prstGeom>
+          <a:noFill/>
+        </p:spPr>
+        <p:txBody>
+          <a:bodyPr wrap="square">
+            <a:spAutoFit/>
+          </a:bodyPr>
+          <a:lstStyle/>
+          <a:p>
+            <a:pPr algn="l">
+              <a:lnSpc>
+                <a:spcPts val="1650"/>
+              </a:lnSpc>
+              <a:spcBef>
+                <a:spcPts val="750"/>
+              </a:spcBef>
+              <a:spcAft>
+                <a:spcPts val="600"/>
+              </a:spcAft>
+              <a:buFont typeface="Arial" panose="020B0604020202020204" pitchFamily="34" charset="0"/>
+              <a:buChar char="•"/>
+            </a:pPr>
+            <a:r>
+              <a:rPr lang="en-US" sz="1600" b="1" i="0" dirty="0" err="1">
+                <a:solidFill>
+                  <a:srgbClr val="EEF0FF"/>
+                </a:solidFill>
+                <a:effectLst/>
+                <a:latin typeface="Google Sans"/>
+                <a:hlinkClick r:id="rId3"/>
+              </a:rPr>
+              <a:t>VirtualService</a:t>
+            </a:r>
+            <a:r>
+              <a:rPr lang="en-US" sz="1600" b="1" i="0" dirty="0">
+                <a:solidFill>
+                  <a:srgbClr val="EEF0FF"/>
+                </a:solidFill>
+                <a:effectLst/>
+                <a:latin typeface="Google Sans"/>
+              </a:rPr>
+              <a:t>:</a:t>
+            </a:r>
+            <a:endParaRPr lang="en-US" sz="1600" b="0" i="0" dirty="0">
+              <a:solidFill>
+                <a:srgbClr val="EEF0FF"/>
+              </a:solidFill>
+              <a:effectLst/>
+              <a:latin typeface="Google Sans"/>
+            </a:endParaRPr>
+          </a:p>
+          <a:p>
+            <a:pPr algn="l">
+              <a:lnSpc>
+                <a:spcPts val="1650"/>
+              </a:lnSpc>
+              <a:spcBef>
+                <a:spcPts val="600"/>
+              </a:spcBef>
+              <a:spcAft>
+                <a:spcPts val="600"/>
+              </a:spcAft>
+              <a:buFont typeface="Arial" panose="020B0604020202020204" pitchFamily="34" charset="0"/>
+              <a:buChar char="•"/>
+            </a:pPr>
+            <a:r>
+              <a:rPr lang="en-US" sz="1600" b="0" i="0" dirty="0">
+                <a:effectLst/>
+                <a:latin typeface="Google Sans"/>
+              </a:rPr>
+              <a:t>Defines a set of traffic routing rules for a given host or set of hosts.</a:t>
+            </a:r>
+          </a:p>
+          <a:p>
+            <a:pPr algn="l">
+              <a:lnSpc>
+                <a:spcPts val="1650"/>
+              </a:lnSpc>
+              <a:spcBef>
+                <a:spcPts val="600"/>
+              </a:spcBef>
+              <a:spcAft>
+                <a:spcPts val="600"/>
+              </a:spcAft>
+              <a:buFont typeface="Arial" panose="020B0604020202020204" pitchFamily="34" charset="0"/>
+              <a:buChar char="•"/>
+            </a:pPr>
+            <a:r>
+              <a:rPr lang="en-US" sz="1600" b="0" i="0" dirty="0">
+                <a:effectLst/>
+                <a:latin typeface="Google Sans"/>
+              </a:rPr>
+              <a:t>Specifies how traffic should be directed based on criteria like HTTP paths, headers, or other conditions.</a:t>
+            </a:r>
+          </a:p>
+          <a:p>
+            <a:pPr algn="l">
+              <a:lnSpc>
+                <a:spcPts val="1650"/>
+              </a:lnSpc>
+              <a:spcBef>
+                <a:spcPts val="600"/>
+              </a:spcBef>
+              <a:spcAft>
+                <a:spcPts val="600"/>
+              </a:spcAft>
+              <a:buFont typeface="Arial" panose="020B0604020202020204" pitchFamily="34" charset="0"/>
+              <a:buChar char="•"/>
+            </a:pPr>
+            <a:r>
+              <a:rPr lang="en-US" sz="1600" b="0" i="0" dirty="0">
+                <a:effectLst/>
+                <a:latin typeface="Google Sans"/>
+              </a:rPr>
+              <a:t>Uses routes to forward traffic to specific destinations, which can include hostnames, subsets (defined in </a:t>
+            </a:r>
+            <a:r>
+              <a:rPr lang="en-US" sz="1600" b="0" i="0" dirty="0" err="1">
+                <a:effectLst/>
+                <a:latin typeface="Google Sans"/>
+              </a:rPr>
+              <a:t>DestinationRules</a:t>
+            </a:r>
+            <a:r>
+              <a:rPr lang="en-US" sz="1600" b="0" i="0" dirty="0">
+                <a:effectLst/>
+                <a:latin typeface="Google Sans"/>
+              </a:rPr>
+              <a:t>), and ports.</a:t>
+            </a:r>
+          </a:p>
+          <a:p>
+            <a:pPr algn="l">
+              <a:lnSpc>
+                <a:spcPts val="1650"/>
+              </a:lnSpc>
+              <a:spcBef>
+                <a:spcPts val="600"/>
+              </a:spcBef>
+              <a:spcAft>
+                <a:spcPts val="1500"/>
+              </a:spcAft>
+              <a:buFont typeface="Arial" panose="020B0604020202020204" pitchFamily="34" charset="0"/>
+              <a:buChar char="•"/>
+            </a:pPr>
+            <a:r>
+              <a:rPr lang="en-US" sz="1600" b="0" i="0" dirty="0">
+                <a:effectLst/>
+                <a:latin typeface="Google Sans"/>
+              </a:rPr>
+              <a:t>Can be used for tasks like A/B testing, canary deployments, and traffic shifting.</a:t>
+            </a:r>
+          </a:p>
+          <a:p>
+            <a:pPr algn="l">
+              <a:lnSpc>
+                <a:spcPts val="1650"/>
+              </a:lnSpc>
+              <a:spcBef>
+                <a:spcPts val="750"/>
+              </a:spcBef>
+              <a:spcAft>
+                <a:spcPts val="1500"/>
+              </a:spcAft>
+              <a:buFont typeface="Arial" panose="020B0604020202020204" pitchFamily="34" charset="0"/>
+              <a:buChar char="•"/>
+            </a:pPr>
+            <a:r>
+              <a:rPr lang="en-US" sz="1600" b="1" i="0" dirty="0" err="1">
+                <a:solidFill>
+                  <a:srgbClr val="EEF0FF"/>
+                </a:solidFill>
+                <a:effectLst/>
+                <a:latin typeface="Google Sans"/>
+                <a:hlinkClick r:id="rId4"/>
+              </a:rPr>
+              <a:t>DestinationRule</a:t>
+            </a:r>
+            <a:r>
+              <a:rPr lang="en-US" sz="1600" b="1" i="0" dirty="0">
+                <a:solidFill>
+                  <a:srgbClr val="EEF0FF"/>
+                </a:solidFill>
+                <a:effectLst/>
+                <a:latin typeface="Google Sans"/>
+              </a:rPr>
+              <a:t>:</a:t>
+            </a:r>
+            <a:endParaRPr lang="en-US" sz="1600" b="0" i="0" dirty="0">
+              <a:solidFill>
+                <a:srgbClr val="EEF0FF"/>
+              </a:solidFill>
+              <a:effectLst/>
+              <a:latin typeface="Google Sans"/>
+            </a:endParaRPr>
+          </a:p>
+          <a:p>
+            <a:pPr algn="l">
+              <a:lnSpc>
+                <a:spcPts val="1650"/>
+              </a:lnSpc>
+              <a:spcBef>
+                <a:spcPts val="600"/>
+              </a:spcBef>
+              <a:spcAft>
+                <a:spcPts val="600"/>
+              </a:spcAft>
+              <a:buFont typeface="Arial" panose="020B0604020202020204" pitchFamily="34" charset="0"/>
+              <a:buChar char="•"/>
+            </a:pPr>
+            <a:r>
+              <a:rPr lang="en-US" sz="1600" b="0" i="0" dirty="0">
+                <a:effectLst/>
+                <a:latin typeface="Google Sans"/>
+              </a:rPr>
+              <a:t>Defines policies that are applied to traffic destined for a service after routing is complete (i.e., after the </a:t>
+            </a:r>
+            <a:r>
+              <a:rPr lang="en-US" sz="1600" b="0" i="0" dirty="0" err="1">
+                <a:effectLst/>
+                <a:latin typeface="Google Sans"/>
+              </a:rPr>
+              <a:t>VirtualService</a:t>
+            </a:r>
+            <a:r>
+              <a:rPr lang="en-US" sz="1600" b="0" i="0" dirty="0">
+                <a:effectLst/>
+                <a:latin typeface="Google Sans"/>
+              </a:rPr>
+              <a:t> has been applied).</a:t>
+            </a:r>
+          </a:p>
+          <a:p>
+            <a:pPr algn="l">
+              <a:lnSpc>
+                <a:spcPts val="1650"/>
+              </a:lnSpc>
+              <a:spcBef>
+                <a:spcPts val="600"/>
+              </a:spcBef>
+              <a:spcAft>
+                <a:spcPts val="600"/>
+              </a:spcAft>
+              <a:buFont typeface="Arial" panose="020B0604020202020204" pitchFamily="34" charset="0"/>
+              <a:buChar char="•"/>
+            </a:pPr>
+            <a:r>
+              <a:rPr lang="en-US" sz="1600" b="0" i="0" dirty="0">
+                <a:effectLst/>
+                <a:latin typeface="Google Sans"/>
+              </a:rPr>
+              <a:t>Can specify how traffic should be load-balanced (e.g., round robin, least connections).</a:t>
+            </a:r>
+          </a:p>
+          <a:p>
+            <a:pPr algn="l">
+              <a:lnSpc>
+                <a:spcPts val="1650"/>
+              </a:lnSpc>
+              <a:spcBef>
+                <a:spcPts val="600"/>
+              </a:spcBef>
+              <a:spcAft>
+                <a:spcPts val="600"/>
+              </a:spcAft>
+              <a:buFont typeface="Arial" panose="020B0604020202020204" pitchFamily="34" charset="0"/>
+              <a:buChar char="•"/>
+            </a:pPr>
+            <a:r>
+              <a:rPr lang="en-US" sz="1600" b="0" i="0" dirty="0">
+                <a:effectLst/>
+                <a:latin typeface="Google Sans"/>
+              </a:rPr>
+              <a:t>Can define subsets of a service, which are groups of instances with specific labels (e.g., version numbers).</a:t>
+            </a:r>
+          </a:p>
+          <a:p>
+            <a:pPr algn="l">
+              <a:lnSpc>
+                <a:spcPts val="1650"/>
+              </a:lnSpc>
+              <a:spcBef>
+                <a:spcPts val="600"/>
+              </a:spcBef>
+              <a:spcAft>
+                <a:spcPts val="1500"/>
+              </a:spcAft>
+              <a:buFont typeface="Arial" panose="020B0604020202020204" pitchFamily="34" charset="0"/>
+              <a:buChar char="•"/>
+            </a:pPr>
+            <a:r>
+              <a:rPr lang="en-US" sz="1600" b="0" i="0" dirty="0">
+                <a:effectLst/>
+                <a:latin typeface="Google Sans"/>
+              </a:rPr>
+              <a:t>Can configure connection pool settings, fault injection (e.g., delays, aborts), and retries. </a:t>
+            </a:r>
+          </a:p>
+        </p:txBody>
+      </p:sp>
+    </p:spTree>
+    <p:extLst>
+      <p:ext uri="{BB962C8B-B14F-4D97-AF65-F5344CB8AC3E}">
+        <p14:creationId xmlns:p14="http://schemas.microsoft.com/office/powerpoint/2010/main" val="3750275333"/>
+      </p:ext>
+    </p:extLst>
+  </p:cSld>
+  <p:clrMapOvr>
+    <a:masterClrMapping/>
+  </p:clrMapOvr>
+</p:sld>
+</file>
+
+<file path=ppt/slides/slide15.xml><?xml version="1.0" encoding="utf-8"?>
+<p:sld xmlns:a="http://schemas.openxmlformats.org/drawingml/2006/main" xmlns:r="http://schemas.openxmlformats.org/officeDocument/2006/relationships" xmlns:p="http://schemas.openxmlformats.org/presentationml/2006/main">
+  <p:cSld>
+    <p:spTree>
+      <p:nvGrpSpPr>
+        <p:cNvPr id="1" name=""/>
+        <p:cNvGrpSpPr/>
+        <p:nvPr/>
+      </p:nvGrpSpPr>
+      <p:grpSpPr>
+        <a:xfrm>
+          <a:off x="0" y="0"/>
+          <a:ext cx="0" cy="0"/>
+          <a:chOff x="0" y="0"/>
+          <a:chExt cx="0" cy="0"/>
+        </a:xfrm>
+      </p:grpSpPr>
+      <p:sp>
+        <p:nvSpPr>
+          <p:cNvPr id="2" name="Title 1">
+            <a:extLst>
+              <a:ext uri="{FF2B5EF4-FFF2-40B4-BE49-F238E27FC236}">
+                <a16:creationId xmlns:a16="http://schemas.microsoft.com/office/drawing/2014/main" id="{020183B1-386F-1E1A-33E5-4FAA38754020}"/>
+              </a:ext>
+            </a:extLst>
+          </p:cNvPr>
+          <p:cNvSpPr>
+            <a:spLocks noGrp="1"/>
+          </p:cNvSpPr>
+          <p:nvPr>
+            <p:ph type="title"/>
+          </p:nvPr>
+        </p:nvSpPr>
+        <p:spPr>
+          <a:xfrm>
+            <a:off x="838200" y="365125"/>
+            <a:ext cx="10515600" cy="483961"/>
+          </a:xfrm>
+        </p:spPr>
+        <p:txBody>
+          <a:bodyPr>
+            <a:normAutofit fontScale="90000"/>
+          </a:bodyPr>
+          <a:lstStyle/>
+          <a:p>
+            <a:r>
+              <a:rPr lang="en-IN" dirty="0"/>
+              <a:t>Installation</a:t>
+            </a:r>
+          </a:p>
+        </p:txBody>
+      </p:sp>
+      <p:sp>
+        <p:nvSpPr>
+          <p:cNvPr id="3" name="TextBox 2">
+            <a:extLst>
+              <a:ext uri="{FF2B5EF4-FFF2-40B4-BE49-F238E27FC236}">
+                <a16:creationId xmlns:a16="http://schemas.microsoft.com/office/drawing/2014/main" id="{5C866065-33F1-9E2F-07D4-7B2566B45875}"/>
+              </a:ext>
+            </a:extLst>
+          </p:cNvPr>
+          <p:cNvSpPr txBox="1"/>
+          <p:nvPr/>
+        </p:nvSpPr>
+        <p:spPr>
+          <a:xfrm>
+            <a:off x="1164771" y="1600200"/>
+            <a:ext cx="8980715" cy="1477328"/>
+          </a:xfrm>
+          <a:prstGeom prst="rect">
+            <a:avLst/>
+          </a:prstGeom>
+          <a:noFill/>
+        </p:spPr>
+        <p:txBody>
+          <a:bodyPr wrap="square" rtlCol="0">
+            <a:spAutoFit/>
+          </a:bodyPr>
+          <a:lstStyle/>
+          <a:p>
+            <a:pPr marL="342900" indent="-342900">
+              <a:buFont typeface="+mj-lt"/>
+              <a:buAutoNum type="arabicPeriod"/>
+            </a:pPr>
+            <a:r>
+              <a:rPr lang="en-IN" dirty="0"/>
+              <a:t>install </a:t>
+            </a:r>
+            <a:r>
+              <a:rPr lang="en-IN" dirty="0" err="1"/>
+              <a:t>istioctl</a:t>
+            </a:r>
+            <a:r>
+              <a:rPr lang="en-IN" dirty="0"/>
+              <a:t> in local</a:t>
+            </a:r>
+          </a:p>
+          <a:p>
+            <a:pPr marL="342900" indent="-342900">
+              <a:buFont typeface="+mj-lt"/>
+              <a:buAutoNum type="arabicPeriod"/>
+            </a:pPr>
+            <a:r>
+              <a:rPr lang="en-IN" dirty="0"/>
+              <a:t>Istio can be installed into an k8s cluster using </a:t>
+            </a:r>
+            <a:r>
+              <a:rPr lang="en-IN" dirty="0" err="1"/>
+              <a:t>istioctl</a:t>
+            </a:r>
+            <a:r>
+              <a:rPr lang="en-IN" dirty="0"/>
+              <a:t> or helm</a:t>
+            </a:r>
+          </a:p>
+          <a:p>
+            <a:pPr marL="342900" indent="-342900">
+              <a:buFont typeface="+mj-lt"/>
+              <a:buAutoNum type="arabicPeriod"/>
+            </a:pPr>
+            <a:r>
+              <a:rPr lang="en-IN" dirty="0"/>
+              <a:t>For automatic </a:t>
+            </a:r>
+            <a:r>
+              <a:rPr lang="en-IN" dirty="0" err="1"/>
+              <a:t>sidecard</a:t>
+            </a:r>
+            <a:r>
+              <a:rPr lang="en-IN" dirty="0"/>
+              <a:t> injection we need to label the namespace </a:t>
+            </a:r>
+            <a:r>
+              <a:rPr lang="en-IN" dirty="0" err="1"/>
+              <a:t>istio</a:t>
+            </a:r>
+            <a:r>
+              <a:rPr lang="en-IN" dirty="0"/>
+              <a:t>-injection=enabled</a:t>
+            </a:r>
+          </a:p>
+          <a:p>
+            <a:pPr marL="342900" indent="-342900">
+              <a:buFont typeface="+mj-lt"/>
+              <a:buAutoNum type="arabicPeriod"/>
+            </a:pPr>
+            <a:r>
+              <a:rPr lang="en-IN" dirty="0"/>
+              <a:t>Deploy the application into this namespace and it should get an automatic sidecar injection</a:t>
+            </a:r>
+          </a:p>
+        </p:txBody>
+      </p:sp>
+    </p:spTree>
+    <p:extLst>
+      <p:ext uri="{BB962C8B-B14F-4D97-AF65-F5344CB8AC3E}">
+        <p14:creationId xmlns:p14="http://schemas.microsoft.com/office/powerpoint/2010/main" val="1027378300"/>
+      </p:ext>
+    </p:extLst>
+  </p:cSld>
+  <p:clrMapOvr>
+    <a:masterClrMapping/>
+  </p:clrMapOvr>
+</p:sld>
+</file>
+
+<file path=ppt/slides/slide16.xml><?xml version="1.0" encoding="utf-8"?>
+<p:sld xmlns:a="http://schemas.openxmlformats.org/drawingml/2006/main" xmlns:r="http://schemas.openxmlformats.org/officeDocument/2006/relationships" xmlns:p="http://schemas.openxmlformats.org/presentationml/2006/main">
+  <p:cSld>
+    <p:spTree>
+      <p:nvGrpSpPr>
+        <p:cNvPr id="1" name=""/>
+        <p:cNvGrpSpPr/>
+        <p:nvPr/>
+      </p:nvGrpSpPr>
+      <p:grpSpPr>
+        <a:xfrm>
+          <a:off x="0" y="0"/>
+          <a:ext cx="0" cy="0"/>
+          <a:chOff x="0" y="0"/>
+          <a:chExt cx="0" cy="0"/>
+        </a:xfrm>
+      </p:grpSpPr>
+      <p:sp>
+        <p:nvSpPr>
+          <p:cNvPr id="2" name="Title 1">
+            <a:extLst>
+              <a:ext uri="{FF2B5EF4-FFF2-40B4-BE49-F238E27FC236}">
                 <a16:creationId xmlns:a16="http://schemas.microsoft.com/office/drawing/2014/main" id="{FB8455DF-6854-D9A7-4176-2511D8C86F76}"/>
               </a:ext>
             </a:extLst>
@@ -3532,7 +5184,7 @@
 </p:sld>
 </file>
 
-<file path=ppt/slides/slide11.xml><?xml version="1.0" encoding="utf-8"?>
+<file path=ppt/slides/slide17.xml><?xml version="1.0" encoding="utf-8"?>
 <p:sld xmlns:a="http://schemas.openxmlformats.org/drawingml/2006/main" xmlns:r="http://schemas.openxmlformats.org/officeDocument/2006/relationships" xmlns:p="http://schemas.openxmlformats.org/presentationml/2006/main">
   <p:cSld>
     <p:spTree>
@@ -3644,7 +5296,7 @@
 </p:sld>
 </file>
 
-<file path=ppt/slides/slide12.xml><?xml version="1.0" encoding="utf-8"?>
+<file path=ppt/slides/slide18.xml><?xml version="1.0" encoding="utf-8"?>
 <p:sld xmlns:a="http://schemas.openxmlformats.org/drawingml/2006/main" xmlns:r="http://schemas.openxmlformats.org/officeDocument/2006/relationships" xmlns:p="http://schemas.openxmlformats.org/presentationml/2006/main">
   <p:cSld>
     <p:spTree>
@@ -3828,7 +5480,7 @@
 </p:sld>
 </file>
 
-<file path=ppt/slides/slide13.xml><?xml version="1.0" encoding="utf-8"?>
+<file path=ppt/slides/slide19.xml><?xml version="1.0" encoding="utf-8"?>
 <p:sld xmlns:a="http://schemas.openxmlformats.org/drawingml/2006/main" xmlns:r="http://schemas.openxmlformats.org/officeDocument/2006/relationships" xmlns:p="http://schemas.openxmlformats.org/presentationml/2006/main">
   <p:cSld>
     <p:spTree>
@@ -5868,7 +7520,15 @@
           <a:p>
             <a:r>
               <a:rPr lang="en-IN" dirty="0"/>
-              <a:t>The package manager for Kubernetes – you can find common helm charts from publicly availed registries</a:t>
+              <a:t>The </a:t>
+            </a:r>
+            <a:r>
+              <a:rPr lang="en-IN" b="1" dirty="0"/>
+              <a:t>package manager for Kubernetes </a:t>
+            </a:r>
+            <a:r>
+              <a:rPr lang="en-IN" dirty="0"/>
+              <a:t>– you can find common helm charts from publicly availed registries</a:t>
             </a:r>
           </a:p>
           <a:p>

</xml_diff>